<commit_message>
docs: speaker-note talking scripts for all slides; full project description in English and Persian (Word)
Co-Authored-By: Claude Sonnet 5.5 <noreply@anthropic.com>
Claude-Session: https://claude.ai/code/session_01MCd92X1TQnJhwpdce7yB5m
</commit_message>
<xml_diff>
--- a/Armani_Data_Science_Presentation.pptx
+++ b/Armani_Data_Science_Presentation.pptx
@@ -126,19 +126,19 @@
   <p:extLst>
     <p:ext uri="{521415D9-36F7-43E2-AB2F-B90AF26B5E84}">
       <p14:sectionLst xmlns:p14="http://schemas.microsoft.com/office/powerpoint/2010/main">
-        <p14:section name="Context" id="{41ca807e-fb4e-3e40-ff0c-cc278489b00f}">
+        <p14:section name="Context" id="{521d4395-0e60-8162-cc54-7ac223b4dcb0}">
           <p14:sldIdLst>
             <p14:sldId id="256"/>
             <p14:sldId id="257"/>
           </p14:sldIdLst>
         </p14:section>
-        <p14:section name="Part 1 - Data" id="{2ed947bf-8dd8-069c-3df3-7b7127059de0}">
+        <p14:section name="Part 1 - Data" id="{7ad03009-3049-4a68-3c0a-108c6a900726}">
           <p14:sldIdLst>
             <p14:sldId id="258"/>
             <p14:sldId id="259"/>
           </p14:sldIdLst>
         </p14:section>
-        <p14:section name="Part 2 - Forecast" id="{35576689-2acf-3cb8-62c0-a36a6c48be7d}">
+        <p14:section name="Part 2 - Forecast" id="{d2955505-411c-0100-0e4e-bcdd00142808}">
           <p14:sldIdLst>
             <p14:sldId id="260"/>
             <p14:sldId id="261"/>
@@ -149,13 +149,13 @@
             <p14:sldId id="266"/>
           </p14:sldIdLst>
         </p14:section>
-        <p14:section name="Part 3 - Dashboard" id="{7fb0bb75-64fd-b999-c283-0042f692e0f0}">
+        <p14:section name="Part 3 - Dashboard" id="{9bdee0b0-010c-2e28-95e3-a9db2c1f86e3}">
           <p14:sldIdLst>
             <p14:sldId id="267"/>
             <p14:sldId id="268"/>
           </p14:sldIdLst>
         </p14:section>
-        <p14:section name="Part 4 - Pricing" id="{8e7fe24e-e538-08bb-2afc-bc35e378d62c}">
+        <p14:section name="Part 4 - Pricing" id="{b3bd9d29-5a22-ccbc-aed7-ce891568641d}">
           <p14:sldIdLst>
             <p14:sldId id="269"/>
             <p14:sldId id="270"/>
@@ -165,7 +165,7 @@
             <p14:sldId id="274"/>
           </p14:sldIdLst>
         </p14:section>
-        <p14:section name="Wrap-up" id="{7bb31de4-0446-5bb0-c377-6ceb373d368e}">
+        <p14:section name="Wrap-up" id="{8810235d-404d-31e9-bf19-8c888def9d08}">
           <p14:sldIdLst>
             <p14:sldId id="275"/>
           </p14:sldIdLst>
@@ -6131,7 +6131,10 @@
           <a:p>
             <a:r>
               <a:rPr lang="en-US" dirty="0"/>
-              <a:t>Welcome. This presentation walks through how I approached the assessment: what problem each part poses, how I investigated it, which technical decisions I made and why, and what the results are. The emphasis is on the reasoning and the method, not only the final numbers.</a:t>
+              <a:t>[Slide 1 - Title, about 30 seconds]
+Good morning, and thank you for the opportunity. My name is Hamidreza Nademi, and this is my technical assessment for the Data Scientist position at Armani Middle East Trading.
+Before I start, let me tell you how I would like you to listen to this presentation. The final numbers matter, but what I care about even more is how I got there: what I looked at first, what surprised me, which decisions I made, and why I believe each decision is right. So for every part I will follow the same pattern: the problem, what the data showed, what I built, how I proved it works, and which assumptions I had to make.
+The solution has four parts: a clean database, a demand forecast, a KPI dashboard, and a dynamic pricing and risk strategy. They are not four separate pieces of work. They form one chain, and I will show you that on the next slide.</a:t>
             </a:r>
             <a:endParaRPr lang="en-US" dirty="0"/>
           </a:p>
@@ -6219,7 +6222,12 @@
           <a:p>
             <a:r>
               <a:rPr lang="en-US" dirty="0"/>
-              <a:t>Average miss (WAPE) of every model over the four test windows, shown twice: on all test weeks (blue), and on unconstrained weeks only (green), where demand equals observed sales and does not depend on the reconstruction. The winner has 4.57 percent on all weeks and 6.64 percent on unconstrained weeks. On unconstrained weeks the top models are practically tied between 6.6 and 6.8 percent: the structure matters, not the model's complexity. Machine learning (LightGBM 4.78 percent, Prophet 4.76 percent) does not beat the shared structure, and per-product classical models are worse. The last-52-week mean (16.8 percent) is omitted from the chart for scale. Errors on unconstrained weeks are higher because reconstructed demand in capped weeks is smooth, while observed weeks carry real noise, so 6.6 percent is the honest accuracy to quote. The winner is statistically better than the best simple rule (paired bootstrap interval excludes zero).</a:t>
+              <a:t>[Slide 10 - Model comparison, about 2.5 minutes]
+Thirteen models competed in this tournament: simple rules of thumb, classic statistics, machine learning, ensembles, and my structural model. All used the same four tests and the same tuning discipline.
+The chart shows each model's average miss, called WAPE, in blue for all test weeks, and in green for unconstrained weeks only. The unconstrained weeks are the ones where demand equals observed sales, so the score does not depend on my reconstruction at all. That is my protection against the criticism that I graded myself on my own target.
+The winner has 4.57 percent on all weeks and 6.64 percent on unconstrained weeks. Compared with the best simple rule it is 13 percent better, and compared with last year's same week it is 34 percent better. A paired bootstrap confirms the gain is real.
+Notice what does not happen. Machine learning does not win: LightGBM gets 4.78 and Prophet 4.76. And on unconstrained weeks the top models are practically tied, between 6.6 and 6.8 percent. This tells me that the structure of the problem matters, not the complexity of the model. A plain size-times-season-times-growth recipe is only 0.15 points behind the winner.
+The honest number to quote is 6.6 percent, because it is measured where demand was observed directly. The 4.57 is lower because the reconstructed demand is smoother in the capped weeks. I would rather give you the conservative number myself than let you discover it.</a:t>
             </a:r>
             <a:endParaRPr lang="en-US" dirty="0"/>
           </a:p>
@@ -6307,7 +6315,12 @@
           <a:p>
             <a:r>
               <a:rPr lang="en-US" dirty="0"/>
-              <a:t>How the dollar figures are computed. Potential revenue: for every product-week the forecast demand (P50) is multiplied by the product's last-13-week average price and summed over 30 products and 26 weeks: 1.998 million units gives $64.6M. Unserved revenue: future stock is unknown, so for each product-week the expected units sold are simulated as min(demand, stock) where stock is drawn from that product's own last 104 weeks of stock available for sales; the expected sold units are 1.09 million, worth $35.8M. The difference, $28.7M (44 percent), is demand that stock history would not serve. Example: Barley week 1: 2,899 units x $7.447 = $21,589 potential; the historical stock lets about 1,397 units sell, worth $10,406; the remaining 1,494 units, $11,182, would be lost. This is a risk view, not a prediction of what will be sold, because purchasing can change.</a:t>
+              <a:t>[Slide 11 - The 26-week forecast, about 2.5 minutes]
+This is the forecast for weeks 261 to 286. Total demand is about 2.0 million units, 2.8 percent above the same weeks a year earlier, with a likely range of 1.84 to 2.15 million. The range comes from the backtest errors, and I checked that it works: 80 percent of the actual outcomes fall inside it.
+Now the dollar figures, because I want you to see exactly how they are built. First, the revenue potential of 64.6 million dollars. For every product-week I take the forecast demand and multiply by the product's last-13-week average price, then add all 780 product-weeks. That is the revenue if every unit demanded could be sold.
+But future stock is unknown, so the next step is a simulation. For each product-week, the units sold are the minimum of demand and stock, where stock is drawn from that product's own last 104 weeks of stock history. The expected result is 1.09 million units, worth 35.8 million dollars. The difference, 28.7 million dollars or 44 percent, is demand that the historical stock levels would not serve.
+Take Barley in week 1: 2,899 units times 7.447 dollars is 21,589 dollars of potential. The stock history lets about 1,397 units sell, worth 10,406 dollars. The remaining 1,494 units, 11,182 dollars, would be lost.
+I want to be clear that this is a risk view, not a prediction of sales, because purchasing can change. But it points to the central message of the whole project: the constraint is availability, not demand.</a:t>
             </a:r>
             <a:endParaRPr lang="en-US" dirty="0"/>
           </a:p>
@@ -6395,7 +6408,11 @@
           <a:p>
             <a:r>
               <a:rPr lang="en-US" dirty="0"/>
-              <a:t>The dashboard turns the data and the forecast into the KPIs the assessment asks for: financial (gross margin, revenue growth, operating profit), operational (inventory turnover, days of stock, service level, lost revenue) and credit (days sales outstanding and a default-risk rating A to E). It also shows the 26-week forecast with a likely range, the recommended prices of Part 4 and six rule-based alerts with editable thresholds. Because the data has no customers or invoices, the credit layer is a scenario with editable assumptions, labelled as such. 24 automatic tests reconcile every KPI to the database. The live dashboard is shown in the demo.</a:t>
+              <a:t>[Slide 12 - The KPI dashboard, about 1.5 minutes, then live demo]
+Part 3 turns the data and the forecast into the KPIs that the assessment asks for. There are four groups. Financial: gross margin, revenue growth and operating profit. Operational: inventory turnover, days of stock, service level and lost revenue. Credit: days sales outstanding and a default-risk rating from A to E. And the forward view: the 26-week forecast with its range, the price plan from Part 4, and six rule-based alerts.
+The numbers at the bottom tell the story. Revenue in the last 52 weeks is 65.4 million dollars, up 3.3 percent. Gross margin is 21.5 percent and flat, so margin is not the problem. The service level is 60 percent: only 60 percent of customer demand is served, and 43.2 million dollars of sales were lost. At default thresholds the dashboard raises 16 high-priority alerts, each with the money at stake and a recommended action.
+Two design choices I want to point out. Credit has no data in the file, so the credit layer is a scenario with editable, clearly labelled assumptions, instead of numbers that pretend to be facts. And I did not trust my own dashboard blindly: 24 automatic tests reconcile every KPI with the database and recompute the alert rules independently.
+At this point I will switch to the live dashboard and show you the overview, the stock and service tab, the credit tab and the alert list. Then I will come back to the credit rating, which deserves its own slide.</a:t>
             </a:r>
             <a:endParaRPr lang="en-US" dirty="0"/>
           </a:p>
@@ -6483,7 +6500,12 @@
           <a:p>
             <a:r>
               <a:rPr lang="en-US" dirty="0"/>
-              <a:t>The rating summarises how risky it is to sell on credit in a product category, from A (lowest risk) to E (highest). Because the data has no customers or invoices, the inputs are scenario assumptions per category: payment terms, share of sales on credit, average payment delay and annual default rate. From them a risk score from 0 to 100 is built from four components, each scaled to 0-100 and capped: default rate (3 percent default = 100) with weight 40 percent, lateness (delay equal to half the terms = 100) 20 percent, expected credit loss relative to gross profit (15 percent = 100) 25 percent, and revenue concentration (25 percent of revenue = 100) 15 percent. Rating bands: A below 20, B below 35, C below 50, D below 65, E 65 and above. Example, Beverages and Cocoa: 0.40 x 60 + 0.20 x 40 + 0.25 x 42 + 0.15 x 71 = 53, rating D. Why it matters: the rating drives decisions: it raises credit alerts in the dashboard and sets the pricing rules of Part 4 (C: markdown capped at 5 percent; D and E: no markdowns, a risk premium and 15 days shorter terms). It is illustrative and should be calibrated with real payment history.</a:t>
+              <a:t>[Slide 13 - The credit-risk rating, about 2 minutes]
+Let me explain the rating from A to E, because it appears in the dashboard and it drives the pricing rules in Part 4.
+What is it? A single letter that summarises how risky it is to sell on credit in a product category: A is the lowest risk, E the highest. Why is it useful? Because managers cannot read four numbers for each category, and because it lets the system act: it raises alerts and it switches pricing rules.
+How is it computed? From a risk score between 0 and 100, a weighted sum of four components. Default rate, weight 40 percent, where a 3 percent annual default is the maximum score. Lateness, 20 percent, where an average delay equal to half the payment terms is the maximum. Loss versus margin, 25 percent: the expected credit loss as a share of gross profit, with 15 percent as the maximum. And concentration, 15 percent: the category's share of revenue, with 25 percent as the maximum. The bands are A below 20, B below 35, C below 50, D below 65 and E above.
+Example: Beverages and Cocoa scores 0.40 times 60, plus 0.20 times 40, plus 0.25 times 42, plus 0.15 times 71, which is 53, so the rating is D. It has long terms, many credit sales and a large share of revenue. Cereals and Spices are C, the rest are B.
+I must be honest about the limits. There is no customer data, so the inputs are scenario assumptions, and the rating is illustrative. The structure is transparent and ready to be calibrated with real payment history.</a:t>
             </a:r>
             <a:endParaRPr lang="en-US" dirty="0"/>
           </a:p>
@@ -6571,7 +6593,12 @@
           <a:p>
             <a:r>
               <a:rPr lang="en-US" dirty="0"/>
-              <a:t>The pricing idea is derived from what the data showed in Parts 1 to 3. Insight 1: 78 percent of the forecast product-weeks are scarce, meaning the stock history would not cover demand, so those products sell out regardless of price. Insight 2: demand swings 25 percent either side of normal over the year, so scarcity is strongest in peak weeks. Insight 3: five products hold 64 to 370 weeks of stock, 10.8 million dollars, so markdowns are only interesting there, and only if they pay. Insight 4: prices vary only 4 percent within a product, so the price effect cannot be measured (-0.017, interval includes zero). Idea: raise prices where stock sells out anyway, because then units are set by stock and the extra price is pure profit; do not rely on price sensitivity; discount only if it provably pays; and keep strict guardrails.</a:t>
+              <a:t>[Slide 14 - Part 4: the pricing idea from the data insights, about 2.5 minutes]
+Now Part 4. Before any formula, I want to give you the whole idea, and show that it comes from the data and not from my imagination.
+Four insights. One: 78 percent of the forecast product-weeks are scarce, meaning the stock history cannot cover the forecast demand. Those products will sell out whatever the price is. Two: demand swings 25 percent above and below normal over the year, so scarcity is strongest in peak weeks. Three: five products hold between 64 and 370 weeks of stock, 10.8 million dollars of capital, so discounting is only interesting there, and only if it pays. Four: prices vary only 4 percent within a product, so the effect of price on demand cannot be measured. The estimated effect is minus 0.017, and the range includes zero.
+These four facts lead to one idea, in the dark band: raise the price where stock sells out anyway, because then the units sold are set by the stock, and the extra price is pure profit. Do not rely on an unknown price sensitivity. Discount only if it provably pays. And keep strict limits.
+The chart shows the rule: no rise when 5 percent or less of demand is unserved, then a rise that grows with scarcity up to 8 percent, scaled by the season. On the right, the three states. Scarce, 78 percent of the plan: raise the price up to 8 percent while units sold stay within 1 percent. Balanced, 5 percent: hold. Surplus, 17 percent: markdown only if profit rises, otherwise fix purchasing.
+Notice the elegance of the logic: it does not need to know the price sensitivity, which is exactly the thing the data cannot tell us.</a:t>
             </a:r>
             <a:endParaRPr lang="en-US" dirty="0"/>
           </a:p>
@@ -6659,7 +6686,11 @@
           <a:p>
             <a:r>
               <a:rPr lang="en-US" dirty="0"/>
-              <a:t>This is the algorithm. Inputs for every product-week: forecast demand with its range, the stock expected to be available, the season on the shared curve (peak at or above 1.10, off-peak at or below 0.90), and the credit rating. Step 1, scarcity premium: if part of the demand cannot be served the product sells out anyway, so the price can rise by up to 8 percent, scaled by how much demand is unserved and by the season. Step 2, sell-out protection: the rise is limited so that expected units sold stay within 1 percent, tested by 1,000 simulated demand draws with customers twice as price-sensitive as assumed. Step 3, surplus markdown: where stock exceeds 26 weeks, a markdown of up to 10 percent is allowed only if simulated profit rises. Step 4, credit risk: ratings D and E get no markdown and a risk premium; C is capped at a 5 percent markdown. Step 5, guardrails: a cost floor, a competitive band and a weekly step limit. The binding limit is recorded for every price so each one can be explained.</a:t>
+              <a:t>[Slide 15 - The pricing engine, about 2 minutes]
+This slide is the algorithm, as a flow you can follow from left to right.
+The inputs for every product-week are the forecast demand with its range, the stock expected to be available, the season on the shared seasonal curve, and the credit rating of the category.
+Step one, the scarcity premium. If part of the demand cannot be served, the product sells out anyway, so the price can rise, from 0 up to 8 percent. Step two, sell-out protection: the rise is capped so that expected units sold stay within 1 percent of today's, tested with 1,000 simulated demand draws and with customers assumed twice as price-sensitive as the planning case. This is my insurance against the unknown price sensitivity. Step three, the surplus markdown: where stock exceeds 26 weeks, a discount of up to 10 percent is allowed, only if the simulated profit rises. Step four, credit risk: ratings D and E get no markdown and pay a risk premium; rating C is capped at a 5 percent markdown. Step five, the guardrails: a cost floor, a competitive band and a weekly step limit, which I will detail shortly.
+The output is a recommended price for each of the 780 product-weeks, together with the reason, including which limit was binding. At the bottom you see a real example: Barley, week 1, from 7.447 to 7.67 dollars, plus 3 percent, because it is scarce and the weekly step was the binding limit. Every price can be explained in one sentence, which is what makes the engine auditable.</a:t>
             </a:r>
             <a:endParaRPr lang="en-US" dirty="0"/>
           </a:p>
@@ -6747,7 +6778,12 @@
           <a:p>
             <a:r>
               <a:rPr lang="en-US" dirty="0"/>
-              <a:t>How prices scale during forecasted demand peaks and lulls. The premium is 8 percent x min(1, g / 30 percent) x the season multiplier, where g is the share of expected demand that cannot be served, and the multiplier is 1.0 in peak weeks (seasonal curve at or above 1.10), 0.75 in normal weeks and 0.5 in off-peak weeks (at or below 0.90). In a peak with 30 percent or more unserved demand the premium is the full 8 percent; in a lull it is only 4 percent; below 5 percent unserved demand there is no premium. Barley illustrates it: forecast demand rises from 2,900 to a peak of 3,566 units in week 13 and falls back; the recommended price follows, rising from 7.67 (limited to 3 percent in week 1) to the 8 percent cap in the peak weeks 5 to 22, then easing to +4 percent as the season turns. A weekly step limit keeps the path smooth.</a:t>
+              <a:t>[Slide 16 - Demand-based adjustments, about 2 minutes]
+The brief asks: how do prices scale during forecast demand peaks and lulls? Here is the precise answer.
+The price rise equals 8 percent, times the smaller of one and the unserved-demand share divided by 30 percent, times a season factor. The season factor is 1.0 in a peak, 0.75 in a normal season and 0.5 in an off-peak season, where peak and off-peak are defined by the shared seasonal curve at or above 1.10, or at or below 0.90.
+The table makes it concrete. If 30 percent or more of the demand is unserved, the rise is the full 8 percent in a peak, 6 in a normal season and 4 in a lull. With 20 percent unserved it is 5.3, 4.0 and 2.7. With 10 percent unserved, 2.7, 2.0 and 1.3. With 5 percent or less, nothing.
+The Barley charts show the rule in action. Above, the forecast demand rises from 2,900 to a peak of about 3,570 in week 13 and falls back. Below, the price follows. In weeks 1 to 3 the 3 percent weekly step limit slows the first rise. In the peak, weeks 5 to 22, the price sits at the plus 8 percent cap. As the season turns in weeks 23 to 26, the premium eases toward plus 4 percent.
+So the answer is: the price moves up and down with forecast scarcity and season, smoothly, never by more than 3 percent a week, and never beyond the caps.</a:t>
             </a:r>
             <a:endParaRPr lang="en-US" dirty="0"/>
           </a:p>
@@ -6835,7 +6871,12 @@
           <a:p>
             <a:r>
               <a:rPr lang="en-US" dirty="0"/>
-              <a:t>Rules by stock situation and season. Lean products (stock below demand, 78 percent of product-weeks) are scarce: the scarcity premium applies, scaled by the season: up to +8 percent in peak, +6 percent in normal and +4 percent in off-peak weeks, always within the sell-out protection and the guardrails. High-stock products (more than 26 weeks of cover, 17 percent of product-weeks, five products) get no premium. A markdown is considered only if profit rises: its depth is up to 10 percent, scaled by how far cover exceeds 26 weeks and by the season (0 in peak, 0.5 in normal, 1.0 in off-peak weeks, because discounting in a demand peak would give away margin). In the tests no markdown paid at the planning price sensitivity; Wheat - Hard Red would need customers 3.5 times as price-sensitive. Price cannot fix 64 to 370 weeks of stock: clearing it within a year would need cuts of 17 to 49 percent, and carrying the excess costs about $1.3M a year, more than the whole pricing gain. The right actions are to stop purchasing and to offer bulk or export deals.</a:t>
+              <a:t>[Slide 17 - Inventory and seasonality sensitivity, about 2.5 minutes]
+The second question in the brief: what are the pricing rules for high-stock versus low-stock products, in peak and off-peak seasons? This grid is the answer.
+Top row, lean products: stock below demand, 78 percent of the product-weeks. They are scarce, so the scarcity premium applies, scaled by the season: up to 8 percent in a peak, 6 in a normal season, 4 in an off-peak season. The reason is that stock, not price, limits their sales, so the premium is almost free money.
+Bottom row, high-stock products: more than 26 weeks of cover, 17 percent of the product-weeks, five products. They never get a premium. In a peak the rule is to hold the price, because discounting while demand is high would give away margin. In a normal season a markdown of up to 5 percent, and in an off-peak season up to 10 percent, but only if the simulation shows that profit rises, counting the saving on carrying cost.
+And here is an honest finding: in the tests, no markdown paid at the planning price sensitivity. Wheat, for example, would need customers to be 3.5 times as price-sensitive as assumed.
+The chart explains why price is not the answer for these products. They tie up 10.8 million dollars. Clearing the stock within a year would need cuts of 17 to 49 percent, and carrying it costs about 1.3 million dollars a year, more than the whole pricing gain. So the recommended action is non-price: stop purchasing until stock is below 26 weeks, and offer bulk or export deals. I think it is important that a pricing engine knows when price is the wrong tool.</a:t>
             </a:r>
             <a:endParaRPr lang="en-US" dirty="0"/>
           </a:p>
@@ -6923,7 +6964,11 @@
           <a:p>
             <a:r>
               <a:rPr lang="en-US" dirty="0"/>
-              <a:t>Two groups of guardrails. Competitive and cost guardrails: the recommended price must stay inside a corridor around today's price. The cost floor is cost + 5 percent markup + four weeks of carrying cost at 12 percent a year, divided by (1 - expected credit loss), so no sale is loss-making. The competitive band is 0.92 to 1.10 times today's price (13-week average); no competitor prices exist in the data, so this average is the proxy for the market, to be replaced by observations. The weekly step is at most 3 percent so customers never see jumps. The Barley price sits in the band with the floor far below. Credit-risk guardrails use the A-E rating: A and B follow the normal rules; C: markdown capped at 5 percent; D and E: no markdowns, a risk premium that covers default loss and funding (share on credit x default rate + DSO/365 x 8 percent funding cost = 2.5 percent for Beverages and Cocoa), and recommended payment terms 15 days shorter, which frees about $361K of cash.</a:t>
+              <a:t>[Slide 18 - Guardrails, about 2.5 minutes]
+The third question: how do I ensure competitive prices and respect credit risk? Two groups of guardrails.
+On the left, the corridor, shown for Barley. The cost floor, 6.27 dollars, is the cost plus a 5 percent markup plus four weeks of carrying cost, divided by one minus the expected credit loss, so no sale is ever loss-making. The competitive band runs from 0.92 to 1.10 times today's price. I want to be transparent: there are no competitor prices in the data, so the 13-week average price is the proxy for the market, and the band is an adjustable parameter to be replaced with observed competitor prices. And the weekly step is at most 3 percent, so customers never see price shocks. The dots show Barley: today's price, the first recommended price of 7.67, and the peak price of 8.04, all inside the green corridor.
+On the right, the credit-risk guardrails, driven by the rating. A and B follow the normal rules. C: the markdown is capped at 5 percent. D and E: no markdowns at all, a risk premium that covers default loss and funding cost, and payment terms 15 days shorter. The premium is the share of credit sales times the default rate, plus DSO over 365 times an 8 percent funding cost, which is 2.5 percent for Beverages and Cocoa. Shortening the terms by 15 days frees about 361 thousand dollars of cash.
+All of this is tested: 19 automatic checks cover the band, the floor, the weekly step, the credit rules and hand-calculated arithmetic, and they all pass.</a:t>
             </a:r>
             <a:endParaRPr lang="en-US" dirty="0"/>
           </a:p>
@@ -7011,7 +7056,11 @@
           <a:p>
             <a:r>
               <a:rPr lang="en-US" dirty="0"/>
-              <a:t>Profit means gross profit minus expected credit losses, versus holding today's price, using the same simulated demand and stock for both. Because prices are raised only where stock sells out anyway, the gain barely depends on how customers react: $1.15M if they are very price-sensitive (-3), $1.30M if they ignore price (0), $1.26M in the planning case (-1). Test 1 simulates 1,000 demand and stock draws per product-week. Test 2 repeats this for five price-sensitivity values. Test 3 replays the last 52 weeks with decisions at weeks 208 and 234 using only past information and a naive same-week-last-year forecast: +$1.43M. Test 4 varies 16 parameter settings (all stay positive, $0.64M to $1.6M) and cuts real demand to 60 percent of the estimate: still +$0.94M. The largest setting risk is the number of units accepted to lose; at 0 percent the gain halves. 19 automatic checks pass: band, floor, weekly step, credit rules, hand-calculated arithmetic and the replay.</a:t>
+              <a:t>[Slide 19 - Validation and impact, about 3 minutes]
+Now the question every manager asks: does it work, and how sure are you? The difficulty is that price sensitivity cannot be measured from this data. So instead of pretending to know it, I designed the engine so that its gain does not depend on it, and I tested that claim four ways.
+One, simulation: 1,000 demand and stock draws for every product-week, comparing the engine with holding today's price, with the same draws on both sides so the difference is purely pricing. Two, I repeated it for price sensitivity from zero to minus three, so the result is a range. Three, a replay of the last 52 weeks, taking decisions at weeks 208 and 234 using only information available at the time, with a naive forecast. That gives a gain of 1.43 million dollars. Four, stress tests: 16 parameter variations, all positive, and a test where the real demand is only 60 percent of my estimate, which still gives 0.94 million dollars.
+The chart is the main result. Over 26 weeks the profit gain is 1.26 million dollars in the planning case, 17 percent of the baseline profit. If customers are very price-sensitive it is 1.15; if they ignore price, 1.30. The gain barely moves, because the engine raises prices only where stock sells out anyway. Units sold change by only minus 0.4 percent.
+The largest remaining risk is how many lost units I accept; at zero percent the gain halves. That is why the final box proposes two eight-week pilots: Pilot A checks that scarce products still sell out at plus 3 and plus 5 percent against matched controls, and Pilot B measures the real price sensitivity on high-stock products. I would not roll this out company-wide before those results.</a:t>
             </a:r>
             <a:endParaRPr lang="en-US" dirty="0"/>
           </a:p>
@@ -7099,7 +7148,11 @@
           <a:p>
             <a:r>
               <a:rPr lang="en-US" dirty="0"/>
-              <a:t>The assessment names three business problems: demand volatility, static prices and credit/liquidity risk. I treated them as one chain: you cannot forecast before the data is trustworthy, you cannot price before you know demand, and a dashboard makes the whole thing usable. For each part I started from a question rather than a technique. Four habits guided every decision: diagnose before modelling, test on unseen data, prefer the simple solution unless evidence says otherwise, and state every assumption and stress it.</a:t>
+              <a:t>[Slide 2 - The brief and my approach, about 2 minutes]
+The assignment names three business problems: demand is volatile, prices are static, and credit and liquidity risk has to be balanced against growth. I treated them as one chain, because they depend on each other. You cannot forecast demand if you do not trust the data. You cannot set prices if you do not know the demand. And a dashboard is what makes the forecast and the prices usable.
+So for each part I did not start from a technique. I started from a question. For the data: can I trust every number, and what does each column really measure? For the forecast: what exactly should I forecast, and how do I prove a model works? For the dashboard: what would a decision-maker do with this on Monday morning? For pricing: where does price really earn money, and what could go wrong?
+Four habits guided every decision, and you will see them again and again. First, diagnose before modelling: understand what the data measures before choosing a method. Second, test on unseen data: every choice is judged on weeks the model has not seen. Third, simple unless proven otherwise: a complex model has to beat a plain rule to earn its place. Fourth, state and stress assumptions: where data is missing I assume openly and I show the range of outcomes instead of one optimistic number.
+Keep these four habits in mind. They explain almost every decision that follows.</a:t>
             </a:r>
             <a:endParaRPr lang="en-US" dirty="0"/>
           </a:p>
@@ -7187,7 +7240,11 @@
           <a:p>
             <a:r>
               <a:rPr lang="en-US" dirty="0"/>
-              <a:t>Every assumption is documented in the notebooks and the README. The three that matter most for decisions are price sensitivity, credit data, and the demand reconstruction; each has a test or a pilot attached.</a:t>
+              <a:t>[Slide 20 - Assumptions and closing, about 2.5 minutes]
+I would like to finish with the assumptions, because a result is only as honest as its assumptions, and I tried to keep each one visible, reasoned and replaceable.
+The synthetic calendar: the file has only week numbers, so I started week 1 on 6 January 2020. No result depends on the actual start date. Sales equal the minimum of demand and stock: verified in the database with zero violations. The legacy forecast as a demand signal: justified because it is unbiased on weeks where the truth is known. Future stock follows each product's own history, because future purchasing is unknown; the dashboard shows both the stock-limited and unconstrained views. Credit terms and default rates: there is no customer data, so they are editable and clearly labelled. Price sensitivity: the data cannot measure it, so results are shown from zero to minus three, and Pilot B will measure it. And the competitor band and the holding and funding costs are adjustable parameters.
+Let me close with the story in one minute. The data hid its own problem: stock limits sales, so sales understate demand. Once demand was reconstructed, a simple structural model, level times growth times season, forecast it better than machine learning, and I can explain it with one example. The dashboard turned this into KPIs and alerts. The pricing engine uses the insight that scarce products sell out anyway, and protects itself against what the data cannot tell. The biggest value is in stock planning: 28.7 million dollars of demand at risk and 10.8 million dollars tied up in five products. Pricing adds about 1.3 million dollars on top, safely.
+Everything is reproducible: five notebooks, one Excel workbook each, a README with the run order. Thank you. I am happy to take your questions, and to go deeper into any step.</a:t>
             </a:r>
             <a:endParaRPr lang="en-US" dirty="0"/>
           </a:p>
@@ -7275,7 +7332,14 @@
           <a:p>
             <a:r>
               <a:rPr lang="en-US" dirty="0"/>
-              <a:t>Design goal: every number in later parts must be trustworthy and every correction traceable. The raw file is copied untouched into a staging table first, so nothing is lost. Validation separates fatal problems (stop the load) from fixable ones (log and correct). Exact duplicates are dropped because a repeated row would double count sales. Missing sales are recovered from revenue / price. Odd values are flagged, not deleted, because later analysis shows they carry information. The load is one transaction so it is repeatable. Exception handling was proven on a deliberately corrupted copy: 15 tests, all passed. The integrity index rises from 79.7 to 99.7.</a:t>
+              <a:t>[Slide 3 - Part 1: the ETL pipeline, about 2 minutes]
+Part 1 is data engineering. The design goal was simple: every number in the later parts must be trustworthy, and every correction must be traceable. The pipeline has five stages.
+One, extract and check. The file and its schema are verified, and an untouched raw copy is stored in a staging table. Nothing is ever lost, so any later question can be answered by going back to the original.
+Two, validate. Problems are typed exceptions. Fatal problems stop the load, and unusable rows go to a quarantine table together with the reason.
+Three, clean. 39 exact duplicate rows were dropped, because a repeated week would double-count sales. Infinite growth values were set to NULL.
+Four, recover and flag. 16 missing sales values were recovered as revenue divided by price. Unusual rows were flagged, not erased, because, as you will see, they turned out to contain information.
+Five, load. A star schema is written in one transaction, with a run log, so the load is repeatable and auditable.
+The chart shows the result: a data-quality index built from five dimensions rises from 79.7 to 99.7. The biggest gains are in derived fields, where only 37 percent of values were consistent, and in stock plausibility. And I did not just claim that the error handling works: I proved it with 15 tests on a deliberately corrupted copy of the file, and all 15 passed.</a:t>
             </a:r>
             <a:endParaRPr lang="en-US" dirty="0"/>
           </a:p>
@@ -7363,7 +7427,11 @@
           <a:p>
             <a:r>
               <a:rPr lang="en-US" dirty="0"/>
-              <a:t>These are the data challenges met in the raw file. Principle: fix what is provably wrong, flag what is merely unusual, and never delete information whose meaning is not yet understood. Duplicates (39) were dropped because a repeated week double counts sales. Missing sales (16) were recovered as revenue divided by price. The 606 missing legacy forecasts were not imputed because that would invent a baseline. 897 infinite growth values were set to NULL and recomputed. Derived fields were only 37 percent consistent, so revenue, profit, margin, growth and turnover were recomputed. The inventory timing issue looked like corruption (907 rows with zero stock but positive sales) but was a misaligned column: sales in a week are limited by the previous row's inventory. Pile-ups at 1,500 and 2,500 and the 1,329 zero-sales weeks looked like errors but are stock caps; they became the key to the whole solution. 23 outliers were flagged with a robust z-score and a winsorised copy added. Dates, customers and competitor prices do not exist in the file, so those parts rely on labelled assumptions.</a:t>
+              <a:t>[Slide 4 - Data challenges, about 2.5 minutes]
+This slide answers the question I expect you to ask: what data problems did you meet, and what did you do about them? There were nine, and for each one I chose a treatment with a reason. My rule was: fix what is provably wrong, flag what is merely unusual, and never delete information whose meaning I do not yet understand.
+The first four are classic. 39 exact duplicates: dropped, because a repeat double-counts sales. 16 missing sales values: recovered as revenue divided by price, because revenue and price were intact. 606 missing legacy forecasts: kept empty and flagged, because filling them would invent a baseline. 897 infinite revenue-growth values, which come from dividing by a zero-revenue week: set to NULL and recomputed. Also, only 37 percent of the derived fields were consistent with their definitions, so revenue, profit, margin, growth and turnover were recomputed from clean inputs.
+The next three are the interesting ones. 907 rows show zero stock but positive sales, which looks like corruption. It was not: sales in a week are limited by the previous row's inventory, so it was a misaligned column. Realigning it gave zero violations. Then 1,329 zero-sales weeks and large pile-ups at exactly 1,500 and 2,500 units. They look like errors, but they are stock caps. I flagged them and kept them, and as you will see on the next slide they became the key to the whole project. And 23 outliers were flagged, with a winsorised copy added, while the original stays untouched.
+Finally, the file has no dates, no customers and no competitor prices. I used a synthetic calendar and labelled scenarios, and I say so everywhere they appear.</a:t>
             </a:r>
             <a:endParaRPr lang="en-US" dirty="0"/>
           </a:p>
@@ -7451,7 +7519,11 @@
           <a:p>
             <a:r>
               <a:rPr lang="en-US" dirty="0"/>
-              <a:t>First the data finding. Sales in a week track the previous row's inventory (correlation 0.85), every one of the 1,329 stock-out weeks has zero sales, and in 2,813 further weeks sales equal the stock exactly, with pile-ups at 1,500 and 2,500. So sales = min(demand, stock): in 53 percent of weeks sales understate demand, and forecasting raw sales would forecast stock availability. Therefore the target is a reconstructed demand column, demand_est, computed per week type. Unconstrained weeks: sales are below stock, so sales are the demand. Stock-limited and stock-out weeks: demand is at least the sales, estimated as the larger of observed sales and a blend of the company's legacy forecast (weight 0.40, validated as unbiased on unconstrained weeks) and a seasonal model (weight 0.60). The three real Barley rows show each case. The blend weight is fitted out-of-fold; on weeks where true demand is known the blend error is 5.0 percent against 7.9 percent for the legacy forecast and 6.6 percent for the model alone. Caveat: unconstrained weeks are slightly biased toward lower demand, so the blend accuracy is an estimate.</a:t>
+              <a:t>[Slide 5 - What the data showed and how demand_est is computed, about 3 minutes]
+This is the most important slide of the project, so let me go slowly. Start at the top: what the data showed. Sales in a week follow the previous row's stock, with a correlation of 0.85. All 1,329 stock-out weeks have zero sales. And in 2,813 more weeks the sales equal the stock exactly, with pile-ups at 1,500 and 2,500.
+The conclusion: sales are not demand. Sales equal the minimum of demand and stock. In 53 percent of the weeks, stock limited what could be sold, so observed sales understate what customers wanted. If I forecast raw sales, I would be forecasting stock availability, and every later decision would be built on that mistake.
+So the target I forecast is a reconstructed column called demand_est, computed differently for each week type, and here are real rows from the dataset, all for Barley. Left: an unconstrained week. Stock was enough, so sales are the demand: 2,201. Middle: a stock-limited week. Sales hit the stock level of 2,500, so demand is at least that. I take the larger of the sales and a blend of two estimates: 40 percent the company's legacy forecast, 60 percent my seasonal model. That gives 2,659, which is 6.4 percent above sales. Right: a stock-out week. Sales are zero because stock is zero, but the blend says customers wanted about 2,925 units.
+Why 40 and 60? I measured it on weeks where the true demand is known: the blend is wrong by 5.0 percent, the legacy forecast by 7.9 and the model alone by 6.6, and the weight was fitted out-of-fold. The legacy forecast looked poor against raw sales, correlation 0.21, but on unconstrained weeks it is 0.97 correlated and unbiased. It was never a bad forecast; it was being compared with censored sales.</a:t>
             </a:r>
             <a:endParaRPr lang="en-US" dirty="0"/>
           </a:p>
@@ -7539,7 +7611,13 @@
           <a:p>
             <a:r>
               <a:rPr lang="en-US" dirty="0"/>
-              <a:t>Feature engineering happened in three layers. Layer A, in the ETL: the most important feature of the project is stock_available_for_sales, the previous row's inventory, which turned an apparent data error into the explanation of the sales pattern; with the censoring status and flags it describes what each sales number really measures. Layer B, in pre-processing: the reconstructed demand target, the seasonal-model prediction, calendar fields from the synthetic dates, and product descriptors: stock regime from k-means and the high-stock versus normal-stock profile. Layer C, model inputs: the structural model needs only product level, trend and sine/cosine pairs of week of year; LightGBM also gets horizon, demand of the same week last year and its neighbours, 13, 26 and 52-week levels and product codes, with the target expressed relative to the 52-week level. The evidence for keeping or dropping features: week of year explains 78 to 86 percent of demand variance against a permutation null, product shapes correlate 0.97, price and cost have no calendar effect, and the within-product price effect is -0.017 (95 percent interval -0.056 to +0.021). LightGBM importance is concentrated in week of year, its sine/cosine terms and last year's pattern. Rules: only information known at the forecast origin is used, and the legacy forecast is never a model input.</a:t>
+              <a:t>[Slide 6 - Feature engineering, about 2.5 minutes]
+Feature engineering is where much of the value of this project sits, and I built features in three layers, each with a purpose.
+Layer A, in the ETL, answers the question: what does each sales number actually measure? The most important feature of the whole project is stock available for sales, which is the previous row's inventory. It turned an apparent data error into the explanation of the sales pattern. Together with the censoring status and the flags for stock-outs, caps, pile-ups and outliers, it tells every later step how much to trust a given row.
+Layer B, in pre-processing, builds the target and the product descriptors: the reconstructed demand, the seasonal-model prediction, calendar fields from the synthetic dates, and the stock regime, found by k-means on stock-out rate, capped-week rate and stock cover.
+Layer C, the model inputs. The winning structural model needs only three things: a product level, a trend and sine and cosine pairs of the week of the year. The machine-learning model gets a richer set: the horizon, the same week last year and its neighbours, 13, 26 and 52-week levels, and product codes, with the target expressed relative to the 52-week level.
+How did I decide what to keep? By evidence. Week of year explains 78 to 86 percent of the demand variance, tested against a permutation null. Products share their yearly shape, with a correlation of 0.97. Price and cost have no calendar effect, and the price effect on demand is minus 0.017, not significant. And the importance chart shows the learner relies almost only on season and last year's pattern.
+Two rules protect the features: only information known at the forecast origin is used, and the legacy forecast is never an input, only a helper in building the target.</a:t>
             </a:r>
             <a:endParaRPr lang="en-US" dirty="0"/>
           </a:p>
@@ -7627,7 +7705,12 @@
           <a:p>
             <a:r>
               <a:rPr lang="en-US" dirty="0"/>
-              <a:t>The model predicts demand_est, the reconstructed units customers wanted, 26 weeks ahead for 30 products: 780 forecasts. Inputs are past demand_est, week of year and the product; the legacy forecast is excluded to avoid leakage. A single train/test split gives one number that depends on which weeks happen to be in the test window: with strong seasonality an easy season flatters the model and a hard one punishes it. A random split would leak the future, because neighbouring weeks and the seasonal pattern would sit in both train and test. So time-ordered rolling splits are used. The origins 156, 182, 208 and 234 make the test windows alternate between the first half (weeks 1 to 26 of the year) and the second half, so every season is tested twice. Each test mimics the real task: learn from the past, forecast 26 weeks. That gives 4 x 26 x 30 = 3,120 test forecasts and four error numbers, which also shows stability: the winner's error stays between 4.3 and 5.1 percent. Inside every training window, the last 52 weeks (two 26-week windows) validate candidate settings; the best setting is refitted on all training weeks. Test weeks never influence a setting.</a:t>
+              <a:t>[Slide 7 - Validation design, about 2.5 minutes]
+Two questions here: what exactly is predicted, and why four tests instead of one train-test split.
+The predicted column is demand_est, the units customers wanted, for 26 weeks ahead and 30 products, so 780 forecasts. The inputs are the past demand, the week of year and the product.
+Now, why not a single split? Four reasons. First, one split gives one number, and with strong seasonality that number depends on which season happens to be in the test window. An easy season flatters a model, a hard one punishes it. Second, the origins I chose, weeks 156, 182, 208 and 234, make the test windows alternate between the first and the second half of the year, so every season is scored twice, peak and lull. Third, I do not use a random split, because shuffled weeks would leak neighbouring weeks and the seasonal pattern into training. Fourth, each test mimics the real task exactly: learn from the past, forecast the next 26 weeks. The final forecast works the same way.
+The diagram shows it. Blue is training. Green is validation: inside every training window, the last 52 weeks are used to choose the model settings. Orange is the test, which never influences any setting.
+This gives 4 times 26 times 30, so 3,120 test forecasts, and four error numbers, which also shows stability. The chart at the bottom shows the winner's error in each test: between 4.3 and 5.1 percent. A model that is good in one test and bad in another would show it here.</a:t>
             </a:r>
             <a:endParaRPr lang="en-US" dirty="0"/>
           </a:p>
@@ -7715,7 +7798,13 @@
           <a:p>
             <a:r>
               <a:rPr lang="en-US" dirty="0"/>
-              <a:t>A free parameter is a model setting that is not learned from the data by the model itself and must be chosen. All were chosen only on validation data inside the training window. The reconstruction model's Fourier order K and trend structure came from blocked five-fold cross-validation with the one-standard-error rule (K=2, shared), and the blend weight 0.40 from out-of-fold predictions. The winning structural model searched K from 1 to 8 and a shared or per-product trend, scoring two inner 26-week windows by WAPE: the final fit selected K=3 with a shared trend (inner WAPE 4.46 percent). Holt-Winters and SARIMAX were chosen by AICc. LightGBM searched 10 random configurations from a grid of leaves, learning rate, minimum leaf size, feature fraction and L2, with early stopping on a trailing 26-week validation block; the number of trees is refitted with 15 percent headroom. Prophet searched changepoint prior, Fourier order and seasonality mode with inner cross-validation on six sample products. The walk-forward ensemble chooses its top three only from earlier folds.</a:t>
+              <a:t>[Slide 8 - Free parameters, about 2 minutes]
+A free parameter is a setting that the model does not learn by itself and that somebody has to choose. How these are chosen is where many forecasting projects quietly cheat, so I want to be transparent.
+The rule is in the box at the bottom: every setting was scored on validation windows inside the training weeks, never on the test weeks. Then the winner is refitted on all training weeks.
+Row by row. For the demand reconstruction, the seasonal model's Fourier order and trend structure came from blocked five-fold cross-validation with the one-standard-error rule: order 2 with a shared trend. The blend weight, 0.40, comes from out-of-fold predictions.
+For the winning structural model I searched Fourier orders 1 to 8 and a shared or per-product trend, 16 combinations, scoring two inner 26-week windows. The final fit selected order 3 with a shared trend.
+Holt-Winters and SARIMAX were chosen by the AICc criterion, per product. LightGBM got 10 random configurations from a grid of leaves, learning rate, minimum leaf size, feature fraction and regularisation, with early stopping on a trailing validation block. Prophet got a grid over changepoint prior, Fourier order and mode, tuned on six sample products. And the walk-forward ensemble picks its top three only from earlier folds.
+The point to remember: every competitor received the same careful tuning, so the comparison on the next slides is fair.</a:t>
             </a:r>
             <a:endParaRPr lang="en-US" dirty="0"/>
           </a:p>
@@ -7803,7 +7892,11 @@
           <a:p>
             <a:r>
               <a:rPr lang="en-US" dirty="0"/>
-              <a:t>The selected model is a pooled log-linear structural model: log demand = product level + trend + a shared seasonal curve written as K sine/cosine pairs of the week of the year. Exponentiated, it is level x growth x season, with a small bias correction because the model works in logs. Each of the three parts was found from a data insight. Level: products differ 5.5 times in size, from 555 units per week (Wheat) to 3,054 (Tea), so every product needs its own size. Growth: demand grew 2.8 percent a year (last 52 weeks against the 52 before), and the STL trend strength is 0.92. Season: week of year explains 78 to 86 percent of demand variance against a permutation null, all 30 products share the same curve (correlation 0.97), peak in week 13 (+25 percent) and trough in week 38 (-25 percent). Price, cost and stock show no demand effect, so they are not in the model. With K=3, only 30 + 1 + 6 = 37 numbers are learned from 7,800 observations because all products share the curve: little room to over-fit. Worked example: Barley, test origin week 234 (tuning picked K=2): 2,579 x 1.057 x 0.983 x 1.002 = 2,687 against 2,505 actual; 26-week miss 4.8 percent for Barley and 4.6 percent for all products.</a:t>
+              <a:t>[Slide 9 - The winning model, about 3 minutes]
+Here is the winner, and I want you to understand it, not just see its score. The idea is one line: the demand of a product in a week equals the product's level, times a growth trend, times a seasonal factor.
+Each of the three parts was found in the data. The product level, because products differ five and a half times in size: from 555 units a week for Wheat to 3,054 for Tea. So every product needs its own size. The growth trend, because demand grew 2.8 percent a year, and a decomposition gives a trend strength of 0.92. The seasonal factor, because the week of the year explains 78 to 86 percent of the variance, and all 30 products follow the same curve with a correlation of 0.97. The peak is week 13, 25 percent above normal, and the quietest week is week 38, 25 percent below.
+Technically the model works in logarithms, where the three parts simply add, and the season is written as sine and cosine pairs. With three pairs it has only 37 numbers to learn: 30 levels, one trend and 6 seasonal coefficients, from 7,800 observations. Because all products share the curve, there is very little room to over-fit. That is why it is hard to beat.
+The example makes it tangible. Barley, first test week, week 235: level 2,579, times a trend of 1.057, times a season of 0.983 because week 27 is slightly quiet, times a tiny bias correction of 1.002, gives 2,687 units. The actual was 2,505. Over the 26 test weeks Barley is missed by 4.8 percent, all products by 4.6. The chart shows the forecast following the real demand closely, including the dip.</a:t>
             </a:r>
             <a:endParaRPr lang="en-US" dirty="0"/>
           </a:p>

</xml_diff>

<commit_message>
docs: expanded project description (English and Persian, about 70 pages each), slide script with 45 prepared Q&A, Q&A pointer in the last slide notes
Co-Authored-By: Claude Sonnet 5.5 <noreply@anthropic.com>
Claude-Session: https://claude.ai/code/session_01MCd92X1TQnJhwpdce7yB5m
</commit_message>
<xml_diff>
--- a/Armani_Data_Science_Presentation.pptx
+++ b/Armani_Data_Science_Presentation.pptx
@@ -126,19 +126,19 @@
   <p:extLst>
     <p:ext uri="{521415D9-36F7-43E2-AB2F-B90AF26B5E84}">
       <p14:sectionLst xmlns:p14="http://schemas.microsoft.com/office/powerpoint/2010/main">
-        <p14:section name="Context" id="{521d4395-0e60-8162-cc54-7ac223b4dcb0}">
+        <p14:section name="Context" id="{27cc3f5c-0f15-2640-651a-dd9c68eebca2}">
           <p14:sldIdLst>
             <p14:sldId id="256"/>
             <p14:sldId id="257"/>
           </p14:sldIdLst>
         </p14:section>
-        <p14:section name="Part 1 - Data" id="{7ad03009-3049-4a68-3c0a-108c6a900726}">
+        <p14:section name="Part 1 - Data" id="{77cfc829-d560-5d4b-a574-2d5203a42683}">
           <p14:sldIdLst>
             <p14:sldId id="258"/>
             <p14:sldId id="259"/>
           </p14:sldIdLst>
         </p14:section>
-        <p14:section name="Part 2 - Forecast" id="{d2955505-411c-0100-0e4e-bcdd00142808}">
+        <p14:section name="Part 2 - Forecast" id="{b1160e3a-a1c9-acd6-5af4-254941239145}">
           <p14:sldIdLst>
             <p14:sldId id="260"/>
             <p14:sldId id="261"/>
@@ -149,13 +149,13 @@
             <p14:sldId id="266"/>
           </p14:sldIdLst>
         </p14:section>
-        <p14:section name="Part 3 - Dashboard" id="{9bdee0b0-010c-2e28-95e3-a9db2c1f86e3}">
+        <p14:section name="Part 3 - Dashboard" id="{06d92423-c25e-92c5-0eec-789880a1a2ff}">
           <p14:sldIdLst>
             <p14:sldId id="267"/>
             <p14:sldId id="268"/>
           </p14:sldIdLst>
         </p14:section>
-        <p14:section name="Part 4 - Pricing" id="{b3bd9d29-5a22-ccbc-aed7-ce891568641d}">
+        <p14:section name="Part 4 - Pricing" id="{3eea8f8a-4369-11b0-6d0c-279de422e2f7}">
           <p14:sldIdLst>
             <p14:sldId id="269"/>
             <p14:sldId id="270"/>
@@ -165,7 +165,7 @@
             <p14:sldId id="274"/>
           </p14:sldIdLst>
         </p14:section>
-        <p14:section name="Wrap-up" id="{8810235d-404d-31e9-bf19-8c888def9d08}">
+        <p14:section name="Wrap-up" id="{f6240464-19e8-5d86-d3b3-c4b4152ad57c}">
           <p14:sldIdLst>
             <p14:sldId id="275"/>
           </p14:sldIdLst>
@@ -7244,7 +7244,17 @@
 I would like to finish with the assumptions, because a result is only as honest as its assumptions, and I tried to keep each one visible, reasoned and replaceable.
 The synthetic calendar: the file has only week numbers, so I started week 1 on 6 January 2020. No result depends on the actual start date. Sales equal the minimum of demand and stock: verified in the database with zero violations. The legacy forecast as a demand signal: justified because it is unbiased on weeks where the truth is known. Future stock follows each product's own history, because future purchasing is unknown; the dashboard shows both the stock-limited and unconstrained views. Credit terms and default rates: there is no customer data, so they are editable and clearly labelled. Price sensitivity: the data cannot measure it, so results are shown from zero to minus three, and Pilot B will measure it. And the competitor band and the holding and funding costs are adjustable parameters.
 Let me close with the story in one minute. The data hid its own problem: stock limits sales, so sales understate demand. Once demand was reconstructed, a simple structural model, level times growth times season, forecast it better than machine learning, and I can explain it with one example. The dashboard turned this into KPIs and alerts. The pricing engine uses the insight that scarce products sell out anyway, and protects itself against what the data cannot tell. The biggest value is in stock planning: 28.7 million dollars of demand at risk and 10.8 million dollars tied up in five products. Pricing adds about 1.3 million dollars on top, safely.
-Everything is reproducible: five notebooks, one Excel workbook each, a README with the run order. Thank you. I am happy to take your questions, and to go deeper into any step.</a:t>
+Everything is reproducible: five notebooks, one Excel workbook each, a README with the run order. Thank you. I am happy to take your questions, and to go deeper into any step.
+[QUESTIONS YOU MAY BE ASKED - short answers. The full list of 45 questions with answers is in Armani_Presentation_Script_and_QA.docx]
+1. Isn't reconstructing demand circular? No: models are also scored on unconstrained weeks, where demand equals observed sales and nothing is reconstructed (6.64 percent error). That is the figure I quote as honest.
+2. Why did machine learning not win? LightGBM and Prophet were tuned as carefully (10 and 8 configurations, validated inside the training window) and are close (4.78 and 4.76 percent), but demand is one shared curve plus a level and a trend, which a structural model with 37 numbers estimates from all products at once.
+3. Why four test windows and not one split? One split gives one number that depends on the season in the window; four windows 26 weeks apart test every season twice, give 3,120 forecasts and show stability (4.3 to 5.1 percent).
+4. You have no price sensitivity. How can you price? I designed the engine so that its gain barely depends on it: prices rise only where stock sells out anyway, the premium is capped so expected units stay within 1 percent even if customers were twice as sensitive, results are shown for 0 to minus 3 (1.15 to 1.30 million dollars), and a pilot measures the real value.
+5. Why was no markdown applied? Over-stocked products would need cuts of 17 to 49 percent even for very price-sensitive customers; 200 candidates were tested and none paid. The right actions are non-price: stop buying, bulk or export deals.
+6. How credible is the credit rating without data? It is a labelled scenario with a transparent, calibratable structure: four weighted components, editable inputs, bands A to E.
+7. What if the demand reconstruction is wrong? At 60 percent of the estimated demand the pricing gain is still 0.94 million dollars; at 50 percent, 0.82 million.
+8. What is your single recommendation? Stop buying the five over-stocked products (10.8 million dollars tied up) and shift capacity to the lean products that sell out (28.7 million dollars of demand at risk); pricing adds about 1.3 million dollars safely.
+</a:t>
             </a:r>
             <a:endParaRPr lang="en-US" dirty="0"/>
           </a:p>

</xml_diff>

<commit_message>
Deck slide 4: use original dataset column names
Co-Authored-By: Claude Sonnet 5.5 <noreply@anthropic.com>
Claude-Session: https://claude.ai/code/session_01MCd92X1TQnJhwpdce7yB5m
</commit_message>
<xml_diff>
--- a/Armani_Data_Science_Presentation.pptx
+++ b/Armani_Data_Science_Presentation.pptx
@@ -126,19 +126,19 @@
   <p:extLst>
     <p:ext uri="{521415D9-36F7-43E2-AB2F-B90AF26B5E84}">
       <p14:sectionLst xmlns:p14="http://schemas.microsoft.com/office/powerpoint/2010/main">
-        <p14:section name="Context" id="{27cc3f5c-0f15-2640-651a-dd9c68eebca2}">
+        <p14:section name="Context" id="{1f109af5-7315-c1dc-2c2f-65311c54c432}">
           <p14:sldIdLst>
             <p14:sldId id="256"/>
             <p14:sldId id="257"/>
           </p14:sldIdLst>
         </p14:section>
-        <p14:section name="Part 1 - Data" id="{77cfc829-d560-5d4b-a574-2d5203a42683}">
+        <p14:section name="Part 1 - Data" id="{abb4bf03-48f1-a86c-723d-856d267a7bc0}">
           <p14:sldIdLst>
             <p14:sldId id="258"/>
             <p14:sldId id="259"/>
           </p14:sldIdLst>
         </p14:section>
-        <p14:section name="Part 2 - Forecast" id="{b1160e3a-a1c9-acd6-5af4-254941239145}">
+        <p14:section name="Part 2 - Forecast" id="{70ae17e9-9e3d-d826-9098-54fdf2e85ee2}">
           <p14:sldIdLst>
             <p14:sldId id="260"/>
             <p14:sldId id="261"/>
@@ -149,13 +149,13 @@
             <p14:sldId id="266"/>
           </p14:sldIdLst>
         </p14:section>
-        <p14:section name="Part 3 - Dashboard" id="{06d92423-c25e-92c5-0eec-789880a1a2ff}">
+        <p14:section name="Part 3 - Dashboard" id="{be477fde-c26c-b173-8f79-bcf9f79c9050}">
           <p14:sldIdLst>
             <p14:sldId id="267"/>
             <p14:sldId id="268"/>
           </p14:sldIdLst>
         </p14:section>
-        <p14:section name="Part 4 - Pricing" id="{3eea8f8a-4369-11b0-6d0c-279de422e2f7}">
+        <p14:section name="Part 4 - Pricing" id="{158064b3-701d-f29c-42d6-834c0b033e47}">
           <p14:sldIdLst>
             <p14:sldId id="269"/>
             <p14:sldId id="270"/>
@@ -165,7 +165,7 @@
             <p14:sldId id="274"/>
           </p14:sldIdLst>
         </p14:section>
-        <p14:section name="Wrap-up" id="{f6240464-19e8-5d86-d3b3-c4b4152ad57c}">
+        <p14:section name="Wrap-up" id="{bbbaf5b7-9567-4390-80b0-7eec58da9bbf}">
           <p14:sldIdLst>
             <p14:sldId id="275"/>
           </p14:sldIdLst>
@@ -7439,8 +7439,8 @@
               <a:rPr lang="en-US" dirty="0"/>
               <a:t>[Slide 4 - Data challenges, about 2.5 minutes]
 This slide answers the question I expect you to ask: what data problems did you meet, and what did you do about them? There were nine, and for each one I chose a treatment with a reason. My rule was: fix what is provably wrong, flag what is merely unusual, and never delete information whose meaning I do not yet understand.
-The first four are classic. 39 exact duplicates: dropped, because a repeat double-counts sales. 16 missing sales values: recovered as revenue divided by price, because revenue and price were intact. 606 missing legacy forecasts: kept empty and flagged, because filling them would invent a baseline. 897 infinite revenue-growth values, which come from dividing by a zero-revenue week: set to NULL and recomputed. Also, only 37 percent of the derived fields were consistent with their definitions, so revenue, profit, margin, growth and turnover were recomputed from clean inputs.
-The next three are the interesting ones. 907 rows show zero stock but positive sales, which looks like corruption. It was not: sales in a week are limited by the previous row's inventory, so it was a misaligned column. Realigning it gave zero violations. Then 1,329 zero-sales weeks and large pile-ups at exactly 1,500 and 2,500 units. They look like errors, but they are stock caps. I flagged them and kept them, and as you will see on the next slide they became the key to the whole project. And 23 outliers were flagged, with a winsorised copy added, while the original stays untouched.
+The first four are classic. 39 duplicate rows, the same Week and Product twice: dropped, because a repeat double-counts sales. 16 missing Sales_Units: recovered as Revenue divided by Price_Per_Unit, because revenue and price were intact. 606 missing Demand_Forecast values: kept empty and flagged, because filling them would invent a baseline. 897 infinite Revenue_Growth values, which come from dividing by a zero-revenue week: set to NULL and recomputed. Also, only 37 percent of the derived columns, such as Revenue and Gross_Profit, were consistent with their definitions, so Revenue, Gross_Profit, Gross_Profit_Margin, Revenue_Growth and Inventory_Turnover_Ratio were recomputed from clean inputs.
+The next three are the interesting ones. 907 rows show Inventory_Level of zero but positive Sales_Units, which looks like corruption. It was not: sales in a week are limited by the previous row's Inventory_Level, so it was a misaligned column. Realigning it gave zero violations. Then 1,329 weeks with Sales_Units equal to zero and large pile-ups at exactly 1,500 and 2,500 units. They look like errors, but they are stock caps. I flagged them and kept them, and as you will see on the next slide they became the key to the whole project. And 23 Sales_Units outliers were flagged, with a winsorised copy added, while the original stays untouched.
 Finally, the file has no dates, no customers and no competitor prices. I used a synthetic calendar and labelled scenarios, and I say so everywhere they appear.</a:t>
             </a:r>
             <a:endParaRPr lang="en-US" dirty="0"/>
@@ -26906,7 +26906,7 @@
                   <a:srgbClr val="1B2A41"/>
                 </a:solidFill>
               </a:rPr>
-              <a:t>exact duplicate rows</a:t>
+              <a:t>duplicate rows (Week, Product)</a:t>
             </a:r>
             <a:endParaRPr lang="en-US" sz="1300" dirty="0"/>
           </a:p>
@@ -27132,7 +27132,7 @@
                   <a:srgbClr val="1B2A41"/>
                 </a:solidFill>
               </a:rPr>
-              <a:t>missing sales values</a:t>
+              <a:t>missing Sales_Units</a:t>
             </a:r>
             <a:endParaRPr lang="en-US" sz="1300" dirty="0"/>
           </a:p>
@@ -27231,7 +27231,7 @@
                   <a:srgbClr val="5B6B80"/>
                 </a:solidFill>
               </a:rPr>
-              <a:t>revenue / price</a:t>
+              <a:t>Revenue / Price_Per_Unit</a:t>
             </a:r>
             <a:endParaRPr lang="en-US" sz="1100" dirty="0"/>
           </a:p>
@@ -27358,7 +27358,7 @@
                   <a:srgbClr val="1B2A41"/>
                 </a:solidFill>
               </a:rPr>
-              <a:t>missing legacy forecasts</a:t>
+              <a:t>missing Demand_Forecast</a:t>
             </a:r>
             <a:endParaRPr lang="en-US" sz="1300" dirty="0"/>
           </a:p>
@@ -27584,7 +27584,7 @@
                   <a:srgbClr val="1B2A41"/>
                 </a:solidFill>
               </a:rPr>
-              <a:t>infinite growth values</a:t>
+              <a:t>infinite Revenue_Growth</a:t>
             </a:r>
             <a:endParaRPr lang="en-US" sz="1300" dirty="0"/>
           </a:p>
@@ -27810,7 +27810,7 @@
                   <a:srgbClr val="1B2A41"/>
                 </a:solidFill>
               </a:rPr>
-              <a:t>of derived fields consistent</a:t>
+              <a:t>of derived columns match (Revenue, Gross_Profit)</a:t>
             </a:r>
             <a:endParaRPr lang="en-US" sz="1300" dirty="0"/>
           </a:p>
@@ -28036,7 +28036,7 @@
                   <a:srgbClr val="1B2A41"/>
                 </a:solidFill>
               </a:rPr>
-              <a:t>rows: zero stock but sales</a:t>
+              <a:t>rows: Inventory_Level = 0 but Sales_Units &gt; 0</a:t>
             </a:r>
             <a:endParaRPr lang="en-US" sz="1300" dirty="0"/>
           </a:p>
@@ -28135,7 +28135,7 @@
                   <a:srgbClr val="5B6B80"/>
                 </a:solidFill>
               </a:rPr>
-              <a:t>stock = previous row's inventory</a:t>
+              <a:t>stock = previous row's Inventory_Level</a:t>
             </a:r>
             <a:endParaRPr lang="en-US" sz="1100" dirty="0"/>
           </a:p>
@@ -28262,7 +28262,7 @@
                   <a:srgbClr val="1B2A41"/>
                 </a:solidFill>
               </a:rPr>
-              <a:t>zero-sales weeks, pile-ups at 1,500 / 2,500</a:t>
+              <a:t>Sales_Units = 0 weeks; pile-ups at 1,500 / 2,500</a:t>
             </a:r>
             <a:endParaRPr lang="en-US" sz="1300" dirty="0"/>
           </a:p>
@@ -28488,7 +28488,7 @@
                   <a:srgbClr val="1B2A41"/>
                 </a:solidFill>
               </a:rPr>
-              <a:t>sales outliers</a:t>
+              <a:t>Sales_Units outliers</a:t>
             </a:r>
             <a:endParaRPr lang="en-US" sz="1300" dirty="0"/>
           </a:p>

</xml_diff>

<commit_message>
Deck: add closing thank-you slide (19 slides)
Co-Authored-By: Claude Sonnet 5.5 <noreply@anthropic.com>
Claude-Session: https://claude.ai/code/session_01MCd92X1TQnJhwpdce7yB5m
</commit_message>
<xml_diff>
--- a/Armani_Data_Science_Presentation.pptx
+++ b/Armani_Data_Science_Presentation.pptx
@@ -23,9 +23,10 @@
     <p:sldId id="271" r:id="rId17"/>
     <p:sldId id="272" r:id="rId18"/>
     <p:sldId id="273" r:id="rId19"/>
+    <p:sldId id="274" r:id="rId20"/>
   </p:sldIdLst>
   <p:notesMasterIdLst>
-    <p:notesMasterId r:id="rId20"/>
+    <p:notesMasterId r:id="rId21"/>
   </p:notesMasterIdLst>
   <p:sldSz cx="12192000" cy="6858000"/>
   <p:notesSz cx="6858000" cy="12192000"/>
@@ -124,19 +125,19 @@
   <p:extLst>
     <p:ext uri="{521415D9-36F7-43E2-AB2F-B90AF26B5E84}">
       <p14:sectionLst xmlns:p14="http://schemas.microsoft.com/office/powerpoint/2010/main">
-        <p14:section name="Context" id="{ca60841a-e02d-1e7e-e723-19a5f943fec0}">
+        <p14:section name="Context" id="{9929c04c-6463-565f-34f9-1321fd42f4b6}">
           <p14:sldIdLst>
             <p14:sldId id="256"/>
             <p14:sldId id="257"/>
           </p14:sldIdLst>
         </p14:section>
-        <p14:section name="Part 1 - Data" id="{86c846e4-7a22-e970-f95a-8f2c9265020e}">
+        <p14:section name="Part 1 - Data" id="{91840678-f02a-4eaa-5bd6-e59e63afc32b}">
           <p14:sldIdLst>
             <p14:sldId id="258"/>
             <p14:sldId id="259"/>
           </p14:sldIdLst>
         </p14:section>
-        <p14:section name="Part 2 - Forecast" id="{646fcc81-bb23-457b-3300-13ac5ba4dc75}">
+        <p14:section name="Part 2 - Forecast" id="{f448bdae-faf3-28a4-c393-db37e6bcfa5c}">
           <p14:sldIdLst>
             <p14:sldId id="260"/>
             <p14:sldId id="261"/>
@@ -146,13 +147,13 @@
             <p14:sldId id="265"/>
           </p14:sldIdLst>
         </p14:section>
-        <p14:section name="Part 3 - Dashboard" id="{a76a0604-2bcc-65d0-0cf2-cb2f12b7dbf4}">
+        <p14:section name="Part 3 - Dashboard" id="{25bdac86-0b73-b0b3-edfc-e5a4a2049fc1}">
           <p14:sldIdLst>
             <p14:sldId id="266"/>
             <p14:sldId id="267"/>
           </p14:sldIdLst>
         </p14:section>
-        <p14:section name="Part 4 - Pricing" id="{e7c25400-e136-a148-e976-2fca6fdb3bfe}">
+        <p14:section name="Part 4 - Pricing" id="{3b998f76-a5e2-f092-fa2e-6e1a6560016f}">
           <p14:sldIdLst>
             <p14:sldId id="268"/>
             <p14:sldId id="269"/>
@@ -160,6 +161,7 @@
             <p14:sldId id="271"/>
             <p14:sldId id="272"/>
             <p14:sldId id="273"/>
+            <p14:sldId id="274"/>
           </p14:sldIdLst>
         </p14:section>
       </p14:sectionLst>
@@ -6995,6 +6997,95 @@
             <a:fld id="{F7021451-1387-4CA6-816F-3879F97B5CBC}" type="slidenum">
               <a:rPr lang="en-US"/>
               <a:t>18</a:t>
+            </a:fld>
+            <a:endParaRPr lang="en-US"/>
+          </a:p>
+        </p:txBody>
+      </p:sp>
+    </p:spTree>
+    <p:extLst>
+      <p:ext uri="{BB962C8B-B14F-4D97-AF65-F5344CB8AC3E}">
+        <p14:creationId xmlns:p14="http://schemas.microsoft.com/office/powerpoint/2010/main" val="1024086991"/>
+      </p:ext>
+    </p:extLst>
+  </p:cSld>
+  <p:clrMapOvr>
+    <a:masterClrMapping/>
+  </p:clrMapOvr>
+</p:notes>
+</file>
+
+<file path=ppt/notesSlides/notesSlide19.xml><?xml version="1.0" encoding="utf-8"?>
+<p:notes xmlns:a="http://schemas.openxmlformats.org/drawingml/2006/main" xmlns:r="http://schemas.openxmlformats.org/officeDocument/2006/relationships" xmlns:p="http://schemas.openxmlformats.org/presentationml/2006/main">
+  <p:cSld>
+    <p:spTree>
+      <p:nvGrpSpPr>
+        <p:cNvPr id="1" name=""/>
+        <p:cNvGrpSpPr/>
+        <p:nvPr/>
+      </p:nvGrpSpPr>
+      <p:grpSpPr>
+        <a:xfrm>
+          <a:off x="0" y="0"/>
+          <a:ext cx="0" cy="0"/>
+          <a:chOff x="0" y="0"/>
+          <a:chExt cx="0" cy="0"/>
+        </a:xfrm>
+      </p:grpSpPr>
+      <p:sp>
+        <p:nvSpPr>
+          <p:cNvPr id="2" name="Slide Image Placeholder 1"/>
+          <p:cNvSpPr>
+            <a:spLocks noGrp="1" noRot="1" noChangeAspect="1"/>
+          </p:cNvSpPr>
+          <p:nvPr>
+            <p:ph type="sldImg"/>
+          </p:nvPr>
+        </p:nvSpPr>
+        <p:spPr/>
+      </p:sp>
+      <p:sp>
+        <p:nvSpPr>
+          <p:cNvPr id="3" name="Notes Placeholder 2"/>
+          <p:cNvSpPr>
+            <a:spLocks noGrp="1"/>
+          </p:cNvSpPr>
+          <p:nvPr>
+            <p:ph type="body" idx="1"/>
+          </p:nvPr>
+        </p:nvSpPr>
+        <p:spPr/>
+        <p:txBody>
+          <a:bodyPr/>
+          <a:lstStyle/>
+          <a:p>
+            <a:r>
+              <a:rPr lang="en-US" dirty="0"/>
+              <a:t>[Slide 19 - Thank you, about 15 seconds]
+Thank you for your attention. I am happy to take your questions, and I can go deeper into any step: the data, the forecast, the dashboard or the pricing engine. If it helps, I can also switch to the live dashboard.</a:t>
+            </a:r>
+            <a:endParaRPr lang="en-US" dirty="0"/>
+          </a:p>
+        </p:txBody>
+      </p:sp>
+      <p:sp>
+        <p:nvSpPr>
+          <p:cNvPr id="4" name="Slide Number Placeholder 3"/>
+          <p:cNvSpPr>
+            <a:spLocks noGrp="1"/>
+          </p:cNvSpPr>
+          <p:nvPr>
+            <p:ph type="sldNum" sz="quarter" idx="10"/>
+          </p:nvPr>
+        </p:nvSpPr>
+        <p:spPr/>
+        <p:txBody>
+          <a:bodyPr/>
+          <a:lstStyle/>
+          <a:p>
+            <a:fld id="{F7021451-1387-4CA6-816F-3879F97B5CBC}" type="slidenum">
+              <a:rPr lang="en-US"/>
+              <a:t>19</a:t>
             </a:fld>
             <a:endParaRPr lang="en-US"/>
           </a:p>
@@ -20941,6 +21032,146 @@
 </p:sld>
 </file>
 
+<file path=ppt/slides/slide19.xml><?xml version="1.0" encoding="utf-8"?>
+<p:sld xmlns:a="http://schemas.openxmlformats.org/drawingml/2006/main" xmlns:r="http://schemas.openxmlformats.org/officeDocument/2006/relationships" xmlns:p="http://schemas.openxmlformats.org/presentationml/2006/main">
+  <p:cSld name="Slide 19">
+    <p:spTree>
+      <p:nvGrpSpPr>
+        <p:cNvPr id="1" name=""/>
+        <p:cNvGrpSpPr/>
+        <p:nvPr/>
+      </p:nvGrpSpPr>
+      <p:grpSpPr>
+        <a:xfrm>
+          <a:off x="0" y="0"/>
+          <a:ext cx="0" cy="0"/>
+          <a:chOff x="0" y="0"/>
+          <a:chExt cx="0" cy="0"/>
+        </a:xfrm>
+      </p:grpSpPr>
+      <p:sp>
+        <p:nvSpPr>
+          <p:cNvPr id="2" name="Text 0"/>
+          <p:cNvSpPr/>
+          <p:nvPr>
+            <p:ph idx="100" type="title" hasCustomPrompt="1"/>
+          </p:nvPr>
+        </p:nvSpPr>
+        <p:spPr>
+          <a:xfrm>
+            <a:off x="822960" y="2103120"/>
+            <a:ext cx="10515600" cy="1737360"/>
+          </a:xfrm>
+          <a:prstGeom prst="rect">
+            <a:avLst/>
+          </a:prstGeom>
+          <a:noFill/>
+          <a:ln/>
+        </p:spPr>
+        <p:txBody>
+          <a:bodyPr wrap="square" lIns="0" tIns="0" rIns="0" bIns="0" rtlCol="0" anchor="t"/>
+          <a:lstStyle/>
+          <a:p>
+            <a:pPr algn="l" indent="0" marL="0">
+              <a:buNone/>
+            </a:pPr>
+            <a:r>
+              <a:rPr lang="en-US" sz="4400" b="1" dirty="0">
+                <a:solidFill>
+                  <a:schemeClr val="bg1"/>
+                </a:solidFill>
+                <a:latin typeface="Cambria" pitchFamily="34" charset="0"/>
+                <a:ea typeface="Cambria" pitchFamily="34" charset="-122"/>
+                <a:cs typeface="Cambria" pitchFamily="34" charset="-120"/>
+              </a:rPr>
+              <a:t>Thanks for your attention</a:t>
+            </a:r>
+            <a:endParaRPr lang="en-US" sz="4400" dirty="0"/>
+          </a:p>
+        </p:txBody>
+      </p:sp>
+      <p:sp>
+        <p:nvSpPr>
+          <p:cNvPr id="3" name="Text 0"/>
+          <p:cNvSpPr/>
+          <p:nvPr>
+            <p:ph idx="101" type="body" hasCustomPrompt="1"/>
+          </p:nvPr>
+        </p:nvSpPr>
+        <p:spPr>
+          <a:xfrm>
+            <a:off x="822960" y="4023360"/>
+            <a:ext cx="10515600" cy="822960"/>
+          </a:xfrm>
+          <a:prstGeom prst="rect">
+            <a:avLst/>
+          </a:prstGeom>
+          <a:noFill/>
+          <a:ln/>
+        </p:spPr>
+        <p:txBody>
+          <a:bodyPr wrap="square" lIns="0" tIns="0" rIns="0" bIns="0" rtlCol="0" anchor="t"/>
+          <a:lstStyle/>
+          <a:p>
+            <a:pPr indent="0" marL="0">
+              <a:buNone/>
+            </a:pPr>
+            <a:r>
+              <a:rPr lang="en-US" sz="2200" dirty="0">
+                <a:solidFill>
+                  <a:srgbClr val="CADCFC"/>
+                </a:solidFill>
+              </a:rPr>
+              <a:t>Questions are welcome</a:t>
+            </a:r>
+            <a:endParaRPr lang="en-US" sz="2200" dirty="0"/>
+          </a:p>
+        </p:txBody>
+      </p:sp>
+      <p:sp>
+        <p:nvSpPr>
+          <p:cNvPr id="4" name="Text 2"/>
+          <p:cNvSpPr txBox="1"/>
+          <p:nvPr/>
+        </p:nvSpPr>
+        <p:spPr>
+          <a:xfrm>
+            <a:off x="822960" y="5852160"/>
+            <a:ext cx="10515600" cy="365760"/>
+          </a:xfrm>
+          <a:prstGeom prst="rect">
+            <a:avLst/>
+          </a:prstGeom>
+          <a:noFill/>
+          <a:ln/>
+        </p:spPr>
+        <p:txBody>
+          <a:bodyPr wrap="square" lIns="0" tIns="0" rIns="0" bIns="0" rtlCol="0" anchor="ctr"/>
+          <a:lstStyle/>
+          <a:p>
+            <a:pPr indent="0" marL="0">
+              <a:buNone/>
+            </a:pPr>
+            <a:r>
+              <a:rPr lang="en-US" sz="1600" dirty="0">
+                <a:solidFill>
+                  <a:srgbClr val="9FB3CC"/>
+                </a:solidFill>
+              </a:rPr>
+              <a:t>Hamidreza Nademi  |  Technical Assessment for Data Scientist Position</a:t>
+            </a:r>
+            <a:endParaRPr lang="en-US" sz="1600" dirty="0"/>
+          </a:p>
+        </p:txBody>
+      </p:sp>
+    </p:spTree>
+  </p:cSld>
+  <p:clrMapOvr>
+    <a:masterClrMapping/>
+  </p:clrMapOvr>
+</p:sld>
+</file>
+
 <file path=ppt/slides/slide2.xml><?xml version="1.0" encoding="utf-8"?>
 <p:sld xmlns:a="http://schemas.openxmlformats.org/drawingml/2006/main" xmlns:r="http://schemas.openxmlformats.org/officeDocument/2006/relationships" xmlns:p="http://schemas.openxmlformats.org/presentationml/2006/main">
   <p:cSld name="Slide 2">

</xml_diff>